<commit_message>
build(docs): regenerate verified exam and five executive slides
</commit_message>
<xml_diff>
--- a/deliverables/Sunset_World_Presentacion_Ejecutiva.pptx
+++ b/deliverables/Sunset_World_Presentacion_Ejecutiva.pptx
@@ -4439,7 +4439,7 @@
               </a:defRPr>
             </a:pPr>
             <a:r>
-              <a:t>Propuesta de implementación. No se han probado en este entorno los servicios empresariales.</a:t>
+              <a:t>5/5 integraciones reales probadas con datos sintéticos; no es certificación de producción.</a:t>
             </a:r>
           </a:p>
         </p:txBody>
@@ -4544,7 +4544,7 @@
               </a:defRPr>
             </a:pPr>
             <a:r>
-              <a:t>Volúmenes: referencia vs evidencia</a:t>
+              <a:t>Volumen: referencia vs estrés físico</a:t>
             </a:r>
           </a:p>
         </p:txBody>
@@ -5227,7 +5227,7 @@
               </a:defRPr>
             </a:pPr>
             <a:r>
-              <a:t>MUESTRA REALMENTE VALIDADA</a:t>
+              <a:t>POSTGRESQL 16: 42.8 M DE FILAS FÍSICAS</a:t>
             </a:r>
           </a:p>
         </p:txBody>
@@ -5263,7 +5263,7 @@
               </a:defRPr>
             </a:pPr>
             <a:r>
-              <a:t>1,000 leads  ·  1,462 cotizaciones FX  ·  600 pagos  ·  1,200 comentarios</a:t>
+              <a:t>9.0M leads  ·  13.8M pagos  ·  20.0M comentarios  ·  0 huérfanos</a:t>
             </a:r>
           </a:p>
         </p:txBody>
@@ -5299,7 +5299,7 @@
               </a:defRPr>
             </a:pPr>
             <a:r>
-              <a:t>La ejecución masiva está parametrizada, pero NO se ha ejecutado: no se muestran benchmarks ficticios.</a:t>
+              <a:t>436.102 s, replay sin duplicados. No es un benchmark end-to-end multi-motor.</a:t>
             </a:r>
           </a:p>
         </p:txBody>
@@ -5920,7 +5920,7 @@
               </a:defRPr>
             </a:pPr>
             <a:r>
-              <a:t>31 pruebas Python: PASS</a:t>
+              <a:t>5/5 integraciones CI: PASS</a:t>
             </a:r>
           </a:p>
           <a:p>
@@ -6018,7 +6018,7 @@
               </a:defRPr>
             </a:pPr>
             <a:r>
-              <a:t>SQLite valida la lógica de la muestra. PostgreSQL y dbt siguen pendientes de ejecución en Docker.</a:t>
+              <a:t>GitHub Actions #39336589227: PostgreSQL, dbt, MinIO, Airflow, Kafka/Spark y RAG PASS.</a:t>
             </a:r>
           </a:p>
         </p:txBody>
@@ -6730,7 +6730,7 @@
               </a:defRPr>
             </a:pPr>
             <a:r>
-              <a:t>Limitación: código implementado, integración Kafka/Spark/pgvector y API Mantis aún no verificadas.</a:t>
+              <a:t>Kafka/Spark y pgvector verificados en CI; API Mantis empresarial aún sin acceso.</a:t>
             </a:r>
           </a:p>
         </p:txBody>
@@ -7551,7 +7551,7 @@
               </a:defRPr>
             </a:pPr>
             <a:r>
-              <a:t>1. Probar Parquet y DW</a:t>
+              <a:t>1. Integración: 5/5 PASS</a:t>
             </a:r>
           </a:p>
           <a:p>
@@ -7564,7 +7564,7 @@
               </a:defRPr>
             </a:pPr>
             <a:r>
-              <a:t>2. Ejecutar Airflow + dbt</a:t>
+              <a:t>2. PostgreSQL 42.8M: PASS</a:t>
             </a:r>
           </a:p>
           <a:p>
@@ -7577,7 +7577,7 @@
               </a:defRPr>
             </a:pPr>
             <a:r>
-              <a:t>3. Validar streaming y RAG</a:t>
+              <a:t>3. Validar Oracle 11g real</a:t>
             </a:r>
           </a:p>
           <a:p>
@@ -7590,7 +7590,7 @@
               </a:defRPr>
             </a:pPr>
             <a:r>
-              <a:t>4. Benchmark volumetría</a:t>
+              <a:t>4. Acordar API Mantis/VPG</a:t>
             </a:r>
           </a:p>
           <a:p>
@@ -7603,7 +7603,7 @@
               </a:defRPr>
             </a:pPr>
             <a:r>
-              <a:t>5. Grabar demo real</a:t>
+              <a:t>5. Dimensionar producción</a:t>
             </a:r>
           </a:p>
         </p:txBody>
@@ -7639,7 +7639,7 @@
               </a:defRPr>
             </a:pPr>
             <a:r>
-              <a:t>Decisiones de negocio pendientes: definición VPG y conversión, reglas de transcripción y API real de Mantis.</a:t>
+              <a:t>Evidencia: GitHub Actions #39336589227 y #39334943627. Datos sintéticos.</a:t>
             </a:r>
           </a:p>
         </p:txBody>

</xml_diff>

<commit_message>
Entrega final: examen PDF, presentación validada, guion y evidencias 42.8M
* docs(release): align exam, slides source and demo script to verified 2026 CI

* build(release): regenerate exam PDF and PPTX in CI, validate contents and retain binaries

* fix(release): install lmodern and typeset long technical tables without overlap

* build(docs): regenerate verified exam and five executive slides

* style(pdf): refine seven-page exam layout with safe text wrapping

* build(docs): regenerate verified exam and five executive slides

---------

Co-authored-by: github-actions[bot] <41898282+github-actions[bot]@users.noreply.github.com>
</commit_message>
<xml_diff>
--- a/deliverables/Sunset_World_Presentacion_Ejecutiva.pptx
+++ b/deliverables/Sunset_World_Presentacion_Ejecutiva.pptx
@@ -4439,7 +4439,7 @@
               </a:defRPr>
             </a:pPr>
             <a:r>
-              <a:t>Propuesta de implementación. No se han probado en este entorno los servicios empresariales.</a:t>
+              <a:t>5/5 integraciones reales probadas con datos sintéticos; no es certificación de producción.</a:t>
             </a:r>
           </a:p>
         </p:txBody>
@@ -4544,7 +4544,7 @@
               </a:defRPr>
             </a:pPr>
             <a:r>
-              <a:t>Volúmenes: referencia vs evidencia</a:t>
+              <a:t>Volumen: referencia vs estrés físico</a:t>
             </a:r>
           </a:p>
         </p:txBody>
@@ -5227,7 +5227,7 @@
               </a:defRPr>
             </a:pPr>
             <a:r>
-              <a:t>MUESTRA REALMENTE VALIDADA</a:t>
+              <a:t>POSTGRESQL 16: 42.8 M DE FILAS FÍSICAS</a:t>
             </a:r>
           </a:p>
         </p:txBody>
@@ -5263,7 +5263,7 @@
               </a:defRPr>
             </a:pPr>
             <a:r>
-              <a:t>1,000 leads  ·  1,462 cotizaciones FX  ·  600 pagos  ·  1,200 comentarios</a:t>
+              <a:t>9.0M leads  ·  13.8M pagos  ·  20.0M comentarios  ·  0 huérfanos</a:t>
             </a:r>
           </a:p>
         </p:txBody>
@@ -5299,7 +5299,7 @@
               </a:defRPr>
             </a:pPr>
             <a:r>
-              <a:t>La ejecución masiva está parametrizada, pero NO se ha ejecutado: no se muestran benchmarks ficticios.</a:t>
+              <a:t>436.102 s, replay sin duplicados. No es un benchmark end-to-end multi-motor.</a:t>
             </a:r>
           </a:p>
         </p:txBody>
@@ -5920,7 +5920,7 @@
               </a:defRPr>
             </a:pPr>
             <a:r>
-              <a:t>31 pruebas Python: PASS</a:t>
+              <a:t>5/5 integraciones CI: PASS</a:t>
             </a:r>
           </a:p>
           <a:p>
@@ -6018,7 +6018,7 @@
               </a:defRPr>
             </a:pPr>
             <a:r>
-              <a:t>SQLite valida la lógica de la muestra. PostgreSQL y dbt siguen pendientes de ejecución en Docker.</a:t>
+              <a:t>GitHub Actions #39336589227: PostgreSQL, dbt, MinIO, Airflow, Kafka/Spark y RAG PASS.</a:t>
             </a:r>
           </a:p>
         </p:txBody>
@@ -6730,7 +6730,7 @@
               </a:defRPr>
             </a:pPr>
             <a:r>
-              <a:t>Limitación: código implementado, integración Kafka/Spark/pgvector y API Mantis aún no verificadas.</a:t>
+              <a:t>Kafka/Spark y pgvector verificados en CI; API Mantis empresarial aún sin acceso.</a:t>
             </a:r>
           </a:p>
         </p:txBody>
@@ -7551,7 +7551,7 @@
               </a:defRPr>
             </a:pPr>
             <a:r>
-              <a:t>1. Probar Parquet y DW</a:t>
+              <a:t>1. Integración: 5/5 PASS</a:t>
             </a:r>
           </a:p>
           <a:p>
@@ -7564,7 +7564,7 @@
               </a:defRPr>
             </a:pPr>
             <a:r>
-              <a:t>2. Ejecutar Airflow + dbt</a:t>
+              <a:t>2. PostgreSQL 42.8M: PASS</a:t>
             </a:r>
           </a:p>
           <a:p>
@@ -7577,7 +7577,7 @@
               </a:defRPr>
             </a:pPr>
             <a:r>
-              <a:t>3. Validar streaming y RAG</a:t>
+              <a:t>3. Validar Oracle 11g real</a:t>
             </a:r>
           </a:p>
           <a:p>
@@ -7590,7 +7590,7 @@
               </a:defRPr>
             </a:pPr>
             <a:r>
-              <a:t>4. Benchmark volumetría</a:t>
+              <a:t>4. Acordar API Mantis/VPG</a:t>
             </a:r>
           </a:p>
           <a:p>
@@ -7603,7 +7603,7 @@
               </a:defRPr>
             </a:pPr>
             <a:r>
-              <a:t>5. Grabar demo real</a:t>
+              <a:t>5. Dimensionar producción</a:t>
             </a:r>
           </a:p>
         </p:txBody>
@@ -7639,7 +7639,7 @@
               </a:defRPr>
             </a:pPr>
             <a:r>
-              <a:t>Decisiones de negocio pendientes: definición VPG y conversión, reglas de transcripción y API real de Mantis.</a:t>
+              <a:t>Evidencia: GitHub Actions #39336589227 y #39334943627. Datos sintéticos.</a:t>
             </a:r>
           </a:p>
         </p:txBody>

</xml_diff>